<commit_message>
Fix photo quality in IC PPTX - crop and resample at 300dpi
</commit_message>
<xml_diff>
--- a/AccountManager_IC_Presentation.pptx
+++ b/AccountManager_IC_Presentation.pptx
@@ -3256,229 +3256,9 @@
           </a:p>
         </p:txBody>
       </p:sp>
-      <p:sp>
-        <p:nvSpPr>
-          <p:cNvPr id="6" name="TextBox 5"/>
-          <p:cNvSpPr txBox="1"/>
-          <p:nvPr/>
-        </p:nvSpPr>
-        <p:spPr>
-          <a:xfrm>
-            <a:off x="274320" y="914400"/>
-            <a:ext cx="8229600" cy="685800"/>
-          </a:xfrm>
-          <a:prstGeom prst="rect">
-            <a:avLst/>
-          </a:prstGeom>
-          <a:noFill/>
-        </p:spPr>
-        <p:txBody>
-          <a:bodyPr wrap="square">
-            <a:spAutoFit/>
-          </a:bodyPr>
-          <a:lstStyle/>
-          <a:p>
-            <a:pPr algn="l"/>
-            <a:r>
-              <a:rPr sz="6000" b="1" i="0">
-                <a:solidFill>
-                  <a:srgbClr val="F4F4F2"/>
-                </a:solidFill>
-                <a:latin typeface="Calibri"/>
-              </a:rPr>
-              <a:t>Myrna</a:t>
-            </a:r>
-          </a:p>
-        </p:txBody>
-      </p:sp>
-      <p:sp>
-        <p:nvSpPr>
-          <p:cNvPr id="7" name="TextBox 6"/>
-          <p:cNvSpPr txBox="1"/>
-          <p:nvPr/>
-        </p:nvSpPr>
-        <p:spPr>
-          <a:xfrm>
-            <a:off x="274320" y="1572768"/>
-            <a:ext cx="8229600" cy="685800"/>
-          </a:xfrm>
-          <a:prstGeom prst="rect">
-            <a:avLst/>
-          </a:prstGeom>
-          <a:noFill/>
-        </p:spPr>
-        <p:txBody>
-          <a:bodyPr wrap="square">
-            <a:spAutoFit/>
-          </a:bodyPr>
-          <a:lstStyle/>
-          <a:p>
-            <a:pPr algn="l"/>
-            <a:r>
-              <a:rPr sz="6000" b="1" i="0">
-                <a:solidFill>
-                  <a:srgbClr val="00C9B1"/>
-                </a:solidFill>
-                <a:latin typeface="Calibri"/>
-              </a:rPr>
-              <a:t>Gamal Fahim</a:t>
-            </a:r>
-          </a:p>
-        </p:txBody>
-      </p:sp>
-      <p:sp>
-        <p:nvSpPr>
-          <p:cNvPr id="8" name="TextBox 7"/>
-          <p:cNvSpPr txBox="1"/>
-          <p:nvPr/>
-        </p:nvSpPr>
-        <p:spPr>
-          <a:xfrm>
-            <a:off x="274320" y="2377440"/>
-            <a:ext cx="8229600" cy="292608"/>
-          </a:xfrm>
-          <a:prstGeom prst="rect">
-            <a:avLst/>
-          </a:prstGeom>
-          <a:noFill/>
-        </p:spPr>
-        <p:txBody>
-          <a:bodyPr wrap="square">
-            <a:spAutoFit/>
-          </a:bodyPr>
-          <a:lstStyle/>
-          <a:p>
-            <a:pPr algn="l"/>
-            <a:r>
-              <a:rPr sz="1300" b="0" i="0">
-                <a:solidFill>
-                  <a:srgbClr val="8B92A5"/>
-                </a:solidFill>
-                <a:latin typeface="Calibri"/>
-              </a:rPr>
-              <a:t>Senior Sales Development Executive  ·  SAP</a:t>
-            </a:r>
-          </a:p>
-        </p:txBody>
-      </p:sp>
-      <p:sp>
-        <p:nvSpPr>
-          <p:cNvPr id="9" name="TextBox 8"/>
-          <p:cNvSpPr txBox="1"/>
-          <p:nvPr/>
-        </p:nvSpPr>
-        <p:spPr>
-          <a:xfrm>
-            <a:off x="274320" y="2670048"/>
-            <a:ext cx="8229600" cy="256032"/>
-          </a:xfrm>
-          <a:prstGeom prst="rect">
-            <a:avLst/>
-          </a:prstGeom>
-          <a:noFill/>
-        </p:spPr>
-        <p:txBody>
-          <a:bodyPr wrap="square">
-            <a:spAutoFit/>
-          </a:bodyPr>
-          <a:lstStyle/>
-          <a:p>
-            <a:pPr algn="l"/>
-            <a:r>
-              <a:rPr sz="1100" b="0" i="0">
-                <a:solidFill>
-                  <a:srgbClr val="8B92A5"/>
-                </a:solidFill>
-                <a:latin typeface="Calibri"/>
-              </a:rPr>
-              <a:t>MEA North  ·  Enterprise Clients</a:t>
-            </a:r>
-          </a:p>
-        </p:txBody>
-      </p:sp>
-      <p:sp>
-        <p:nvSpPr>
-          <p:cNvPr id="10" name="Rectangle 9"/>
-          <p:cNvSpPr/>
-          <p:nvPr/>
-        </p:nvSpPr>
-        <p:spPr>
-          <a:xfrm>
-            <a:off x="274320" y="3035808"/>
-            <a:ext cx="2743200" cy="25400"/>
-          </a:xfrm>
-          <a:prstGeom prst="rect">
-            <a:avLst/>
-          </a:prstGeom>
-          <a:solidFill>
-            <a:srgbClr val="00C9B1"/>
-          </a:solidFill>
-          <a:ln>
-            <a:noFill/>
-          </a:ln>
-        </p:spPr>
-        <p:style>
-          <a:lnRef idx="1">
-            <a:schemeClr val="accent1"/>
-          </a:lnRef>
-          <a:fillRef idx="3">
-            <a:schemeClr val="accent1"/>
-          </a:fillRef>
-          <a:effectRef idx="2">
-            <a:schemeClr val="accent1"/>
-          </a:effectRef>
-          <a:fontRef idx="minor">
-            <a:schemeClr val="lt1"/>
-          </a:fontRef>
-        </p:style>
-        <p:txBody>
-          <a:bodyPr rtlCol="0" anchor="ctr"/>
-          <a:lstStyle/>
-          <a:p>
-            <a:pPr algn="ctr"/>
-          </a:p>
-        </p:txBody>
-      </p:sp>
-      <p:sp>
-        <p:nvSpPr>
-          <p:cNvPr id="11" name="TextBox 10"/>
-          <p:cNvSpPr txBox="1"/>
-          <p:nvPr/>
-        </p:nvSpPr>
-        <p:spPr>
-          <a:xfrm>
-            <a:off x="274320" y="3154680"/>
-            <a:ext cx="8046720" cy="868680"/>
-          </a:xfrm>
-          <a:prstGeom prst="rect">
-            <a:avLst/>
-          </a:prstGeom>
-          <a:noFill/>
-        </p:spPr>
-        <p:txBody>
-          <a:bodyPr wrap="square">
-            <a:spAutoFit/>
-          </a:bodyPr>
-          <a:lstStyle/>
-          <a:p>
-            <a:pPr algn="l"/>
-            <a:r>
-              <a:rPr sz="1300" b="0" i="0">
-                <a:solidFill>
-                  <a:srgbClr val="F4F4F2"/>
-                </a:solidFill>
-                <a:latin typeface="Calibri"/>
-              </a:rPr>
-              <a:t>I want to own a client relationship completely.
-To be the person they call, the person they trust,
-and the person who makes them successful.</a:t>
-            </a:r>
-          </a:p>
-        </p:txBody>
-      </p:sp>
       <p:pic>
         <p:nvPicPr>
-          <p:cNvPr id="12" name="Picture 11" descr="myrna.png"/>
+          <p:cNvPr id="6" name="Picture 5" descr="image.png"/>
           <p:cNvPicPr>
             <a:picLocks noChangeAspect="1"/>
           </p:cNvPicPr>
@@ -3492,14 +3272,234 @@
         </p:blipFill>
         <p:spPr>
           <a:xfrm>
-            <a:off x="9235440" y="457200"/>
-            <a:ext cx="2560320" cy="2560320"/>
+            <a:off x="9326880" y="411480"/>
+            <a:ext cx="2377440" cy="2377440"/>
           </a:xfrm>
           <a:prstGeom prst="rect">
             <a:avLst/>
           </a:prstGeom>
         </p:spPr>
       </p:pic>
+      <p:sp>
+        <p:nvSpPr>
+          <p:cNvPr id="7" name="TextBox 6"/>
+          <p:cNvSpPr txBox="1"/>
+          <p:nvPr/>
+        </p:nvSpPr>
+        <p:spPr>
+          <a:xfrm>
+            <a:off x="274320" y="914400"/>
+            <a:ext cx="8229600" cy="685800"/>
+          </a:xfrm>
+          <a:prstGeom prst="rect">
+            <a:avLst/>
+          </a:prstGeom>
+          <a:noFill/>
+        </p:spPr>
+        <p:txBody>
+          <a:bodyPr wrap="square">
+            <a:spAutoFit/>
+          </a:bodyPr>
+          <a:lstStyle/>
+          <a:p>
+            <a:pPr algn="l"/>
+            <a:r>
+              <a:rPr sz="6000" b="1" i="0">
+                <a:solidFill>
+                  <a:srgbClr val="F4F4F2"/>
+                </a:solidFill>
+                <a:latin typeface="Calibri"/>
+              </a:rPr>
+              <a:t>Myrna</a:t>
+            </a:r>
+          </a:p>
+        </p:txBody>
+      </p:sp>
+      <p:sp>
+        <p:nvSpPr>
+          <p:cNvPr id="8" name="TextBox 7"/>
+          <p:cNvSpPr txBox="1"/>
+          <p:nvPr/>
+        </p:nvSpPr>
+        <p:spPr>
+          <a:xfrm>
+            <a:off x="274320" y="1572768"/>
+            <a:ext cx="8229600" cy="685800"/>
+          </a:xfrm>
+          <a:prstGeom prst="rect">
+            <a:avLst/>
+          </a:prstGeom>
+          <a:noFill/>
+        </p:spPr>
+        <p:txBody>
+          <a:bodyPr wrap="square">
+            <a:spAutoFit/>
+          </a:bodyPr>
+          <a:lstStyle/>
+          <a:p>
+            <a:pPr algn="l"/>
+            <a:r>
+              <a:rPr sz="6000" b="1" i="0">
+                <a:solidFill>
+                  <a:srgbClr val="00C9B1"/>
+                </a:solidFill>
+                <a:latin typeface="Calibri"/>
+              </a:rPr>
+              <a:t>Gamal Fahim</a:t>
+            </a:r>
+          </a:p>
+        </p:txBody>
+      </p:sp>
+      <p:sp>
+        <p:nvSpPr>
+          <p:cNvPr id="9" name="TextBox 8"/>
+          <p:cNvSpPr txBox="1"/>
+          <p:nvPr/>
+        </p:nvSpPr>
+        <p:spPr>
+          <a:xfrm>
+            <a:off x="274320" y="2377440"/>
+            <a:ext cx="8229600" cy="292608"/>
+          </a:xfrm>
+          <a:prstGeom prst="rect">
+            <a:avLst/>
+          </a:prstGeom>
+          <a:noFill/>
+        </p:spPr>
+        <p:txBody>
+          <a:bodyPr wrap="square">
+            <a:spAutoFit/>
+          </a:bodyPr>
+          <a:lstStyle/>
+          <a:p>
+            <a:pPr algn="l"/>
+            <a:r>
+              <a:rPr sz="1300" b="0" i="0">
+                <a:solidFill>
+                  <a:srgbClr val="8B92A5"/>
+                </a:solidFill>
+                <a:latin typeface="Calibri"/>
+              </a:rPr>
+              <a:t>Senior Sales Development Executive  ·  SAP</a:t>
+            </a:r>
+          </a:p>
+        </p:txBody>
+      </p:sp>
+      <p:sp>
+        <p:nvSpPr>
+          <p:cNvPr id="10" name="TextBox 9"/>
+          <p:cNvSpPr txBox="1"/>
+          <p:nvPr/>
+        </p:nvSpPr>
+        <p:spPr>
+          <a:xfrm>
+            <a:off x="274320" y="2670048"/>
+            <a:ext cx="8229600" cy="256032"/>
+          </a:xfrm>
+          <a:prstGeom prst="rect">
+            <a:avLst/>
+          </a:prstGeom>
+          <a:noFill/>
+        </p:spPr>
+        <p:txBody>
+          <a:bodyPr wrap="square">
+            <a:spAutoFit/>
+          </a:bodyPr>
+          <a:lstStyle/>
+          <a:p>
+            <a:pPr algn="l"/>
+            <a:r>
+              <a:rPr sz="1100" b="0" i="0">
+                <a:solidFill>
+                  <a:srgbClr val="8B92A5"/>
+                </a:solidFill>
+                <a:latin typeface="Calibri"/>
+              </a:rPr>
+              <a:t>MEA North  ·  Enterprise Clients</a:t>
+            </a:r>
+          </a:p>
+        </p:txBody>
+      </p:sp>
+      <p:sp>
+        <p:nvSpPr>
+          <p:cNvPr id="11" name="Rectangle 10"/>
+          <p:cNvSpPr/>
+          <p:nvPr/>
+        </p:nvSpPr>
+        <p:spPr>
+          <a:xfrm>
+            <a:off x="274320" y="3035808"/>
+            <a:ext cx="2743200" cy="25400"/>
+          </a:xfrm>
+          <a:prstGeom prst="rect">
+            <a:avLst/>
+          </a:prstGeom>
+          <a:solidFill>
+            <a:srgbClr val="00C9B1"/>
+          </a:solidFill>
+          <a:ln>
+            <a:noFill/>
+          </a:ln>
+        </p:spPr>
+        <p:style>
+          <a:lnRef idx="1">
+            <a:schemeClr val="accent1"/>
+          </a:lnRef>
+          <a:fillRef idx="3">
+            <a:schemeClr val="accent1"/>
+          </a:fillRef>
+          <a:effectRef idx="2">
+            <a:schemeClr val="accent1"/>
+          </a:effectRef>
+          <a:fontRef idx="minor">
+            <a:schemeClr val="lt1"/>
+          </a:fontRef>
+        </p:style>
+        <p:txBody>
+          <a:bodyPr rtlCol="0" anchor="ctr"/>
+          <a:lstStyle/>
+          <a:p>
+            <a:pPr algn="ctr"/>
+          </a:p>
+        </p:txBody>
+      </p:sp>
+      <p:sp>
+        <p:nvSpPr>
+          <p:cNvPr id="12" name="TextBox 11"/>
+          <p:cNvSpPr txBox="1"/>
+          <p:nvPr/>
+        </p:nvSpPr>
+        <p:spPr>
+          <a:xfrm>
+            <a:off x="274320" y="3154680"/>
+            <a:ext cx="8046720" cy="868680"/>
+          </a:xfrm>
+          <a:prstGeom prst="rect">
+            <a:avLst/>
+          </a:prstGeom>
+          <a:noFill/>
+        </p:spPr>
+        <p:txBody>
+          <a:bodyPr wrap="square">
+            <a:spAutoFit/>
+          </a:bodyPr>
+          <a:lstStyle/>
+          <a:p>
+            <a:pPr algn="l"/>
+            <a:r>
+              <a:rPr sz="1300" b="0" i="0">
+                <a:solidFill>
+                  <a:srgbClr val="F4F4F2"/>
+                </a:solidFill>
+                <a:latin typeface="Calibri"/>
+              </a:rPr>
+              <a:t>I want to own a client relationship completely.
+To be the person they call, the person they trust,
+and the person who makes them successful.</a:t>
+            </a:r>
+          </a:p>
+        </p:txBody>
+      </p:sp>
       <p:sp>
         <p:nvSpPr>
           <p:cNvPr id="13" name="Rectangle 12"/>

</xml_diff>